<commit_message>
clean up & update
</commit_message>
<xml_diff>
--- a/Presentation.pptx
+++ b/Presentation.pptx
@@ -132,7 +132,10 @@
 <file path=ppt/revisionInfo.xml><?xml version="1.0" encoding="utf-8"?>
 <p1510:revInfo xmlns:a="http://schemas.openxmlformats.org/drawingml/2006/main" xmlns:r="http://schemas.openxmlformats.org/officeDocument/2006/relationships" xmlns:p1510="http://schemas.microsoft.com/office/powerpoint/2015/10/main">
   <p1510:revLst>
+    <p1510:client id="{292E4F1F-EAEE-D5B9-122B-24F4AD4E6237}" v="15" dt="2022-12-03T19:25:02.166"/>
+    <p1510:client id="{610A9A35-9DD6-469B-37A3-3A83E9EBEEEC}" v="114" dt="2022-12-03T19:17:43.012"/>
     <p1510:client id="{6B198FDA-8F05-7F4A-B3BD-9719BB4EFB5A}" v="580" dt="2022-12-01T20:21:28.693"/>
+    <p1510:client id="{9A8D2D20-2202-916E-09A7-FFB4DFCBA11F}" v="38" dt="2022-12-03T00:07:52.619"/>
   </p1510:revLst>
 </p1510:revInfo>
 </file>
@@ -160,6 +163,61 @@
             <ac:spMk id="3" creationId="{853F99FF-13D1-3667-9BA5-74E7A1063B19}"/>
           </ac:spMkLst>
         </pc:spChg>
+      </pc:sldChg>
+    </pc:docChg>
+  </pc:docChgLst>
+  <pc:docChgLst>
+    <pc:chgData name="Francesco Riccardi" userId="S::10651584@polimi.it::6c83885c-cd25-44a2-9b68-5a6ed639437c" providerId="AD" clId="Web-{292E4F1F-EAEE-D5B9-122B-24F4AD4E6237}"/>
+    <pc:docChg chg="modSld">
+      <pc:chgData name="Francesco Riccardi" userId="S::10651584@polimi.it::6c83885c-cd25-44a2-9b68-5a6ed639437c" providerId="AD" clId="Web-{292E4F1F-EAEE-D5B9-122B-24F4AD4E6237}" dt="2022-12-03T19:25:02.166" v="13" actId="14100"/>
+      <pc:docMkLst>
+        <pc:docMk/>
+      </pc:docMkLst>
+      <pc:sldChg chg="addSp delSp modSp">
+        <pc:chgData name="Francesco Riccardi" userId="S::10651584@polimi.it::6c83885c-cd25-44a2-9b68-5a6ed639437c" providerId="AD" clId="Web-{292E4F1F-EAEE-D5B9-122B-24F4AD4E6237}" dt="2022-12-03T19:24:48.228" v="9" actId="14100"/>
+        <pc:sldMkLst>
+          <pc:docMk/>
+          <pc:sldMk cId="1739851156" sldId="256"/>
+        </pc:sldMkLst>
+        <pc:spChg chg="mod">
+          <ac:chgData name="Francesco Riccardi" userId="S::10651584@polimi.it::6c83885c-cd25-44a2-9b68-5a6ed639437c" providerId="AD" clId="Web-{292E4F1F-EAEE-D5B9-122B-24F4AD4E6237}" dt="2022-12-03T19:24:32.258" v="4" actId="1076"/>
+          <ac:spMkLst>
+            <pc:docMk/>
+            <pc:sldMk cId="1739851156" sldId="256"/>
+            <ac:spMk id="4" creationId="{97F1A706-2FC5-4163-712D-7EDE744E35EE}"/>
+          </ac:spMkLst>
+        </pc:spChg>
+        <pc:picChg chg="add mod">
+          <ac:chgData name="Francesco Riccardi" userId="S::10651584@polimi.it::6c83885c-cd25-44a2-9b68-5a6ed639437c" providerId="AD" clId="Web-{292E4F1F-EAEE-D5B9-122B-24F4AD4E6237}" dt="2022-12-03T19:24:48.228" v="9" actId="14100"/>
+          <ac:picMkLst>
+            <pc:docMk/>
+            <pc:sldMk cId="1739851156" sldId="256"/>
+            <ac:picMk id="2" creationId="{8E3B592B-882C-27FF-8A0A-FBE0BCFB4D02}"/>
+          </ac:picMkLst>
+        </pc:picChg>
+        <pc:picChg chg="del">
+          <ac:chgData name="Francesco Riccardi" userId="S::10651584@polimi.it::6c83885c-cd25-44a2-9b68-5a6ed639437c" providerId="AD" clId="Web-{292E4F1F-EAEE-D5B9-122B-24F4AD4E6237}" dt="2022-12-03T19:24:41.290" v="6"/>
+          <ac:picMkLst>
+            <pc:docMk/>
+            <pc:sldMk cId="1739851156" sldId="256"/>
+            <ac:picMk id="1026" creationId="{EB8EB7EE-659F-07C9-A2F3-8B871CF80120}"/>
+          </ac:picMkLst>
+        </pc:picChg>
+      </pc:sldChg>
+      <pc:sldChg chg="addSp modSp">
+        <pc:chgData name="Francesco Riccardi" userId="S::10651584@polimi.it::6c83885c-cd25-44a2-9b68-5a6ed639437c" providerId="AD" clId="Web-{292E4F1F-EAEE-D5B9-122B-24F4AD4E6237}" dt="2022-12-03T19:25:02.166" v="13" actId="14100"/>
+        <pc:sldMkLst>
+          <pc:docMk/>
+          <pc:sldMk cId="1997099775" sldId="257"/>
+        </pc:sldMkLst>
+        <pc:picChg chg="add mod">
+          <ac:chgData name="Francesco Riccardi" userId="S::10651584@polimi.it::6c83885c-cd25-44a2-9b68-5a6ed639437c" providerId="AD" clId="Web-{292E4F1F-EAEE-D5B9-122B-24F4AD4E6237}" dt="2022-12-03T19:25:02.166" v="13" actId="14100"/>
+          <ac:picMkLst>
+            <pc:docMk/>
+            <pc:sldMk cId="1997099775" sldId="257"/>
+            <ac:picMk id="4" creationId="{E02AD754-C79A-99CE-3C00-38A8F37E5DF8}"/>
+          </ac:picMkLst>
+        </pc:picChg>
       </pc:sldChg>
     </pc:docChg>
   </pc:docChgLst>
@@ -920,6 +978,109 @@
     </pc:docChg>
   </pc:docChgLst>
   <pc:docChgLst>
+    <pc:chgData clId="Web-{605A890F-118E-8D66-729E-36927C71C6EF}"/>
+    <pc:docChg chg="modSld">
+      <pc:chgData name="" userId="" providerId="" clId="Web-{605A890F-118E-8D66-729E-36927C71C6EF}" dt="2022-11-24T21:35:48.322" v="23" actId="20577"/>
+      <pc:docMkLst>
+        <pc:docMk/>
+      </pc:docMkLst>
+      <pc:sldChg chg="modSp">
+        <pc:chgData name="" userId="" providerId="" clId="Web-{605A890F-118E-8D66-729E-36927C71C6EF}" dt="2022-11-24T21:35:48.322" v="23" actId="20577"/>
+        <pc:sldMkLst>
+          <pc:docMk/>
+          <pc:sldMk cId="1739851156" sldId="256"/>
+        </pc:sldMkLst>
+        <pc:spChg chg="mod">
+          <ac:chgData name="" userId="" providerId="" clId="Web-{605A890F-118E-8D66-729E-36927C71C6EF}" dt="2022-11-24T21:35:48.322" v="23" actId="20577"/>
+          <ac:spMkLst>
+            <pc:docMk/>
+            <pc:sldMk cId="1739851156" sldId="256"/>
+            <ac:spMk id="3" creationId="{853F99FF-13D1-3667-9BA5-74E7A1063B19}"/>
+          </ac:spMkLst>
+        </pc:spChg>
+      </pc:sldChg>
+    </pc:docChg>
+  </pc:docChgLst>
+  <pc:docChgLst>
+    <pc:chgData name="Francesco Riccardi" userId="S::10651584@polimi.it::6c83885c-cd25-44a2-9b68-5a6ed639437c" providerId="AD" clId="Web-{9A8D2D20-2202-916E-09A7-FFB4DFCBA11F}"/>
+    <pc:docChg chg="modSld">
+      <pc:chgData name="Francesco Riccardi" userId="S::10651584@polimi.it::6c83885c-cd25-44a2-9b68-5a6ed639437c" providerId="AD" clId="Web-{9A8D2D20-2202-916E-09A7-FFB4DFCBA11F}" dt="2022-12-03T00:07:50.572" v="39" actId="20577"/>
+      <pc:docMkLst>
+        <pc:docMk/>
+      </pc:docMkLst>
+      <pc:sldChg chg="modSp">
+        <pc:chgData name="Francesco Riccardi" userId="S::10651584@polimi.it::6c83885c-cd25-44a2-9b68-5a6ed639437c" providerId="AD" clId="Web-{9A8D2D20-2202-916E-09A7-FFB4DFCBA11F}" dt="2022-12-03T00:07:50.572" v="39" actId="20577"/>
+        <pc:sldMkLst>
+          <pc:docMk/>
+          <pc:sldMk cId="1739851156" sldId="256"/>
+        </pc:sldMkLst>
+        <pc:spChg chg="mod">
+          <ac:chgData name="Francesco Riccardi" userId="S::10651584@polimi.it::6c83885c-cd25-44a2-9b68-5a6ed639437c" providerId="AD" clId="Web-{9A8D2D20-2202-916E-09A7-FFB4DFCBA11F}" dt="2022-12-03T00:07:50.572" v="39" actId="20577"/>
+          <ac:spMkLst>
+            <pc:docMk/>
+            <pc:sldMk cId="1739851156" sldId="256"/>
+            <ac:spMk id="3" creationId="{853F99FF-13D1-3667-9BA5-74E7A1063B19}"/>
+          </ac:spMkLst>
+        </pc:spChg>
+      </pc:sldChg>
+      <pc:sldChg chg="modSp">
+        <pc:chgData name="Francesco Riccardi" userId="S::10651584@polimi.it::6c83885c-cd25-44a2-9b68-5a6ed639437c" providerId="AD" clId="Web-{9A8D2D20-2202-916E-09A7-FFB4DFCBA11F}" dt="2022-12-03T00:06:18.819" v="2" actId="20577"/>
+        <pc:sldMkLst>
+          <pc:docMk/>
+          <pc:sldMk cId="2442836954" sldId="264"/>
+        </pc:sldMkLst>
+        <pc:spChg chg="mod">
+          <ac:chgData name="Francesco Riccardi" userId="S::10651584@polimi.it::6c83885c-cd25-44a2-9b68-5a6ed639437c" providerId="AD" clId="Web-{9A8D2D20-2202-916E-09A7-FFB4DFCBA11F}" dt="2022-12-03T00:06:18.819" v="2" actId="20577"/>
+          <ac:spMkLst>
+            <pc:docMk/>
+            <pc:sldMk cId="2442836954" sldId="264"/>
+            <ac:spMk id="3" creationId="{101064D0-B8B8-4055-6947-2A6F2A6739A8}"/>
+          </ac:spMkLst>
+        </pc:spChg>
+      </pc:sldChg>
+    </pc:docChg>
+  </pc:docChgLst>
+  <pc:docChgLst>
+    <pc:chgData name="Francesco Riccardi" userId="S::10651584@polimi.it::6c83885c-cd25-44a2-9b68-5a6ed639437c" providerId="AD" clId="Web-{610A9A35-9DD6-469B-37A3-3A83E9EBEEEC}"/>
+    <pc:docChg chg="modSld">
+      <pc:chgData name="Francesco Riccardi" userId="S::10651584@polimi.it::6c83885c-cd25-44a2-9b68-5a6ed639437c" providerId="AD" clId="Web-{610A9A35-9DD6-469B-37A3-3A83E9EBEEEC}" dt="2022-12-03T19:17:42.075" v="65" actId="20577"/>
+      <pc:docMkLst>
+        <pc:docMk/>
+      </pc:docMkLst>
+      <pc:sldChg chg="modSp">
+        <pc:chgData name="Francesco Riccardi" userId="S::10651584@polimi.it::6c83885c-cd25-44a2-9b68-5a6ed639437c" providerId="AD" clId="Web-{610A9A35-9DD6-469B-37A3-3A83E9EBEEEC}" dt="2022-12-03T19:17:42.075" v="65" actId="20577"/>
+        <pc:sldMkLst>
+          <pc:docMk/>
+          <pc:sldMk cId="1739851156" sldId="256"/>
+        </pc:sldMkLst>
+        <pc:spChg chg="mod">
+          <ac:chgData name="Francesco Riccardi" userId="S::10651584@polimi.it::6c83885c-cd25-44a2-9b68-5a6ed639437c" providerId="AD" clId="Web-{610A9A35-9DD6-469B-37A3-3A83E9EBEEEC}" dt="2022-12-03T19:17:42.075" v="65" actId="20577"/>
+          <ac:spMkLst>
+            <pc:docMk/>
+            <pc:sldMk cId="1739851156" sldId="256"/>
+            <ac:spMk id="3" creationId="{853F99FF-13D1-3667-9BA5-74E7A1063B19}"/>
+          </ac:spMkLst>
+        </pc:spChg>
+        <pc:spChg chg="mod">
+          <ac:chgData name="Francesco Riccardi" userId="S::10651584@polimi.it::6c83885c-cd25-44a2-9b68-5a6ed639437c" providerId="AD" clId="Web-{610A9A35-9DD6-469B-37A3-3A83E9EBEEEC}" dt="2022-12-03T19:16:58.621" v="19" actId="1076"/>
+          <ac:spMkLst>
+            <pc:docMk/>
+            <pc:sldMk cId="1739851156" sldId="256"/>
+            <ac:spMk id="5" creationId="{2B4857E0-45B5-7215-40F3-088E2058ED04}"/>
+          </ac:spMkLst>
+        </pc:spChg>
+        <pc:spChg chg="mod">
+          <ac:chgData name="Francesco Riccardi" userId="S::10651584@polimi.it::6c83885c-cd25-44a2-9b68-5a6ed639437c" providerId="AD" clId="Web-{610A9A35-9DD6-469B-37A3-3A83E9EBEEEC}" dt="2022-12-03T19:17:28.950" v="62" actId="1076"/>
+          <ac:spMkLst>
+            <pc:docMk/>
+            <pc:sldMk cId="1739851156" sldId="256"/>
+            <ac:spMk id="9" creationId="{BB42A9AD-33ED-2FCD-C936-79A867C92F6A}"/>
+          </ac:spMkLst>
+        </pc:spChg>
+      </pc:sldChg>
+    </pc:docChg>
+  </pc:docChgLst>
+  <pc:docChgLst>
     <pc:chgData name="Francesco Riccardi" userId="S::10651584@polimi.it::6c83885c-cd25-44a2-9b68-5a6ed639437c" providerId="AD" clId="Web-{C8AD9FEC-D413-F76D-F64D-374BE8EB4656}"/>
     <pc:docChg chg="modSld">
       <pc:chgData name="Francesco Riccardi" userId="S::10651584@polimi.it::6c83885c-cd25-44a2-9b68-5a6ed639437c" providerId="AD" clId="Web-{C8AD9FEC-D413-F76D-F64D-374BE8EB4656}" dt="2022-11-25T19:10:11.987" v="4" actId="20577"/>
@@ -967,30 +1128,6 @@
       </pc:sldChg>
     </pc:docChg>
   </pc:docChgLst>
-  <pc:docChgLst>
-    <pc:chgData clId="Web-{605A890F-118E-8D66-729E-36927C71C6EF}"/>
-    <pc:docChg chg="modSld">
-      <pc:chgData name="" userId="" providerId="" clId="Web-{605A890F-118E-8D66-729E-36927C71C6EF}" dt="2022-11-24T21:35:48.322" v="23" actId="20577"/>
-      <pc:docMkLst>
-        <pc:docMk/>
-      </pc:docMkLst>
-      <pc:sldChg chg="modSp">
-        <pc:chgData name="" userId="" providerId="" clId="Web-{605A890F-118E-8D66-729E-36927C71C6EF}" dt="2022-11-24T21:35:48.322" v="23" actId="20577"/>
-        <pc:sldMkLst>
-          <pc:docMk/>
-          <pc:sldMk cId="1739851156" sldId="256"/>
-        </pc:sldMkLst>
-        <pc:spChg chg="mod">
-          <ac:chgData name="" userId="" providerId="" clId="Web-{605A890F-118E-8D66-729E-36927C71C6EF}" dt="2022-11-24T21:35:48.322" v="23" actId="20577"/>
-          <ac:spMkLst>
-            <pc:docMk/>
-            <pc:sldMk cId="1739851156" sldId="256"/>
-            <ac:spMk id="3" creationId="{853F99FF-13D1-3667-9BA5-74E7A1063B19}"/>
-          </ac:spMkLst>
-        </pc:spChg>
-      </pc:sldChg>
-    </pc:docChg>
-  </pc:docChgLst>
 </pc:chgInfo>
 </file>
 
@@ -1076,7 +1213,7 @@
           <a:p>
             <a:fld id="{482AB732-9DE6-2E4C-8B49-BF5F82478A63}" type="datetimeFigureOut">
               <a:rPr lang="en-IT" smtClean="0"/>
-              <a:t>01/12/2022</a:t>
+              <a:t>12/03/2022</a:t>
             </a:fld>
             <a:endParaRPr lang="en-IT"/>
           </a:p>
@@ -1235,7 +1372,7 @@
           <a:p>
             <a:fld id="{60344E58-F240-784F-9798-091271167C92}" type="slidenum">
               <a:rPr lang="en-IT" smtClean="0"/>
-              <a:t>‹#›</a:t>
+              <a:t>‹N›</a:t>
             </a:fld>
             <a:endParaRPr lang="en-IT"/>
           </a:p>
@@ -1645,7 +1782,7 @@
           <a:p>
             <a:fld id="{7AF5F0DC-CC35-F44C-88E7-57B10D8AE085}" type="datetimeFigureOut">
               <a:rPr lang="en-US" smtClean="0"/>
-              <a:t>12/1/22</a:t>
+              <a:t>12/3/2022</a:t>
             </a:fld>
             <a:endParaRPr lang="en-US"/>
           </a:p>
@@ -1687,7 +1824,7 @@
           <a:p>
             <a:fld id="{9348759C-0D7B-6140-9821-9B60A244C910}" type="slidenum">
               <a:rPr lang="en-US" smtClean="0"/>
-              <a:t>‹#›</a:t>
+              <a:t>‹N›</a:t>
             </a:fld>
             <a:endParaRPr lang="en-US"/>
           </a:p>
@@ -1992,7 +2129,7 @@
           <a:p>
             <a:fld id="{7AF5F0DC-CC35-F44C-88E7-57B10D8AE085}" type="datetimeFigureOut">
               <a:rPr lang="en-US" smtClean="0"/>
-              <a:t>12/1/22</a:t>
+              <a:t>12/3/2022</a:t>
             </a:fld>
             <a:endParaRPr lang="en-US"/>
           </a:p>
@@ -2034,7 +2171,7 @@
           <a:p>
             <a:fld id="{9348759C-0D7B-6140-9821-9B60A244C910}" type="slidenum">
               <a:rPr lang="en-US" smtClean="0"/>
-              <a:t>‹#›</a:t>
+              <a:t>‹N›</a:t>
             </a:fld>
             <a:endParaRPr lang="en-US"/>
           </a:p>
@@ -2307,7 +2444,7 @@
           <a:p>
             <a:fld id="{7AF5F0DC-CC35-F44C-88E7-57B10D8AE085}" type="datetimeFigureOut">
               <a:rPr lang="en-US" smtClean="0"/>
-              <a:t>12/1/22</a:t>
+              <a:t>12/3/2022</a:t>
             </a:fld>
             <a:endParaRPr lang="en-US"/>
           </a:p>
@@ -2349,7 +2486,7 @@
           <a:p>
             <a:fld id="{9348759C-0D7B-6140-9821-9B60A244C910}" type="slidenum">
               <a:rPr lang="en-US" smtClean="0"/>
-              <a:t>‹#›</a:t>
+              <a:t>‹N›</a:t>
             </a:fld>
             <a:endParaRPr lang="en-US"/>
           </a:p>
@@ -2567,7 +2704,7 @@
           <a:p>
             <a:fld id="{7AF5F0DC-CC35-F44C-88E7-57B10D8AE085}" type="datetimeFigureOut">
               <a:rPr lang="en-US" smtClean="0"/>
-              <a:t>12/1/22</a:t>
+              <a:t>12/3/2022</a:t>
             </a:fld>
             <a:endParaRPr lang="en-US"/>
           </a:p>
@@ -2609,7 +2746,7 @@
           <a:p>
             <a:fld id="{9348759C-0D7B-6140-9821-9B60A244C910}" type="slidenum">
               <a:rPr lang="en-US" smtClean="0"/>
-              <a:t>‹#›</a:t>
+              <a:t>‹N›</a:t>
             </a:fld>
             <a:endParaRPr lang="en-US"/>
           </a:p>
@@ -2987,7 +3124,7 @@
           <a:p>
             <a:fld id="{7AF5F0DC-CC35-F44C-88E7-57B10D8AE085}" type="datetimeFigureOut">
               <a:rPr lang="en-US" smtClean="0"/>
-              <a:t>12/1/22</a:t>
+              <a:t>12/3/2022</a:t>
             </a:fld>
             <a:endParaRPr lang="en-US"/>
           </a:p>
@@ -3029,7 +3166,7 @@
           <a:p>
             <a:fld id="{9348759C-0D7B-6140-9821-9B60A244C910}" type="slidenum">
               <a:rPr lang="en-US" smtClean="0"/>
-              <a:t>‹#›</a:t>
+              <a:t>‹N›</a:t>
             </a:fld>
             <a:endParaRPr lang="en-US"/>
           </a:p>
@@ -3314,7 +3451,7 @@
           <a:p>
             <a:fld id="{7AF5F0DC-CC35-F44C-88E7-57B10D8AE085}" type="datetimeFigureOut">
               <a:rPr lang="en-US" smtClean="0"/>
-              <a:t>12/1/22</a:t>
+              <a:t>12/3/2022</a:t>
             </a:fld>
             <a:endParaRPr lang="en-US"/>
           </a:p>
@@ -3356,7 +3493,7 @@
           <a:p>
             <a:fld id="{9348759C-0D7B-6140-9821-9B60A244C910}" type="slidenum">
               <a:rPr lang="en-US" smtClean="0"/>
-              <a:t>‹#›</a:t>
+              <a:t>‹N›</a:t>
             </a:fld>
             <a:endParaRPr lang="en-US"/>
           </a:p>
@@ -3871,7 +4008,7 @@
           <a:p>
             <a:fld id="{7AF5F0DC-CC35-F44C-88E7-57B10D8AE085}" type="datetimeFigureOut">
               <a:rPr lang="en-US" smtClean="0"/>
-              <a:t>12/1/22</a:t>
+              <a:t>12/3/2022</a:t>
             </a:fld>
             <a:endParaRPr lang="en-US"/>
           </a:p>
@@ -3913,7 +4050,7 @@
           <a:p>
             <a:fld id="{9348759C-0D7B-6140-9821-9B60A244C910}" type="slidenum">
               <a:rPr lang="en-US" smtClean="0"/>
-              <a:t>‹#›</a:t>
+              <a:t>‹N›</a:t>
             </a:fld>
             <a:endParaRPr lang="en-US"/>
           </a:p>
@@ -4079,7 +4216,7 @@
           <a:p>
             <a:fld id="{7AF5F0DC-CC35-F44C-88E7-57B10D8AE085}" type="datetimeFigureOut">
               <a:rPr lang="en-US" smtClean="0"/>
-              <a:t>12/1/22</a:t>
+              <a:t>12/3/2022</a:t>
             </a:fld>
             <a:endParaRPr lang="en-US"/>
           </a:p>
@@ -4121,7 +4258,7 @@
           <a:p>
             <a:fld id="{9348759C-0D7B-6140-9821-9B60A244C910}" type="slidenum">
               <a:rPr lang="en-US" smtClean="0"/>
-              <a:t>‹#›</a:t>
+              <a:t>‹N›</a:t>
             </a:fld>
             <a:endParaRPr lang="en-US"/>
           </a:p>
@@ -4305,7 +4442,7 @@
           <a:p>
             <a:fld id="{7AF5F0DC-CC35-F44C-88E7-57B10D8AE085}" type="datetimeFigureOut">
               <a:rPr lang="en-US" smtClean="0"/>
-              <a:t>12/1/22</a:t>
+              <a:t>12/3/2022</a:t>
             </a:fld>
             <a:endParaRPr lang="en-US"/>
           </a:p>
@@ -4347,7 +4484,7 @@
           <a:p>
             <a:fld id="{9348759C-0D7B-6140-9821-9B60A244C910}" type="slidenum">
               <a:rPr lang="en-US" smtClean="0"/>
-              <a:t>‹#›</a:t>
+              <a:t>‹N›</a:t>
             </a:fld>
             <a:endParaRPr lang="en-US"/>
           </a:p>
@@ -4687,7 +4824,7 @@
           <a:p>
             <a:fld id="{7AF5F0DC-CC35-F44C-88E7-57B10D8AE085}" type="datetimeFigureOut">
               <a:rPr lang="en-US" smtClean="0"/>
-              <a:t>12/1/22</a:t>
+              <a:t>12/3/2022</a:t>
             </a:fld>
             <a:endParaRPr lang="en-US"/>
           </a:p>
@@ -4729,7 +4866,7 @@
           <a:p>
             <a:fld id="{9348759C-0D7B-6140-9821-9B60A244C910}" type="slidenum">
               <a:rPr lang="en-US" smtClean="0"/>
-              <a:t>‹#›</a:t>
+              <a:t>‹N›</a:t>
             </a:fld>
             <a:endParaRPr lang="en-US"/>
           </a:p>
@@ -5103,7 +5240,7 @@
           <a:p>
             <a:fld id="{7AF5F0DC-CC35-F44C-88E7-57B10D8AE085}" type="datetimeFigureOut">
               <a:rPr lang="en-US" smtClean="0"/>
-              <a:t>12/1/22</a:t>
+              <a:t>12/3/2022</a:t>
             </a:fld>
             <a:endParaRPr lang="en-US"/>
           </a:p>
@@ -5145,7 +5282,7 @@
           <a:p>
             <a:fld id="{9348759C-0D7B-6140-9821-9B60A244C910}" type="slidenum">
               <a:rPr lang="en-US" smtClean="0"/>
-              <a:t>‹#›</a:t>
+              <a:t>‹N›</a:t>
             </a:fld>
             <a:endParaRPr lang="en-US"/>
           </a:p>
@@ -5427,7 +5564,7 @@
           <a:p>
             <a:fld id="{7AF5F0DC-CC35-F44C-88E7-57B10D8AE085}" type="datetimeFigureOut">
               <a:rPr lang="en-US" smtClean="0"/>
-              <a:t>12/1/22</a:t>
+              <a:t>12/3/2022</a:t>
             </a:fld>
             <a:endParaRPr lang="en-US"/>
           </a:p>
@@ -5505,7 +5642,7 @@
           <a:p>
             <a:fld id="{9348759C-0D7B-6140-9821-9B60A244C910}" type="slidenum">
               <a:rPr lang="en-US" smtClean="0"/>
-              <a:t>‹#›</a:t>
+              <a:t>‹N›</a:t>
             </a:fld>
             <a:endParaRPr lang="en-US"/>
           </a:p>
@@ -5974,7 +6111,7 @@
         <p:spPr>
           <a:xfrm>
             <a:off x="181474" y="230"/>
-            <a:ext cx="5357600" cy="1160213"/>
+            <a:ext cx="5426872" cy="2282431"/>
           </a:xfrm>
         </p:spPr>
         <p:txBody>
@@ -5984,96 +6121,165 @@
           <a:lstStyle/>
           <a:p>
             <a:r>
-              <a:rPr lang="en-US">
+              <a:rPr lang="en-US" sz="1400" dirty="0">
                 <a:cs typeface="Calibri"/>
               </a:rPr>
               <a:t>Lo </a:t>
             </a:r>
             <a:r>
-              <a:rPr lang="en-US" err="1">
+              <a:rPr lang="en-US" sz="1400" dirty="0" err="1">
                 <a:cs typeface="Calibri"/>
               </a:rPr>
               <a:t>sputo</a:t>
             </a:r>
             <a:r>
-              <a:rPr lang="en-US">
+              <a:rPr lang="en-US" sz="1400" dirty="0">
                 <a:cs typeface="Calibri"/>
               </a:rPr>
               <a:t> del </a:t>
             </a:r>
             <a:r>
-              <a:rPr lang="en-US" err="1">
+              <a:rPr lang="en-US" sz="1400" dirty="0" err="1">
                 <a:cs typeface="Calibri"/>
               </a:rPr>
               <a:t>secolo</a:t>
             </a:r>
             <a:r>
-              <a:rPr lang="en-US">
+              <a:rPr lang="en-US" sz="1400" dirty="0">
                 <a:cs typeface="Calibri"/>
               </a:rPr>
               <a:t>, </a:t>
             </a:r>
             <a:r>
-              <a:rPr lang="en-US" err="1">
+              <a:rPr lang="en-US" sz="1400" dirty="0" err="1">
                 <a:cs typeface="Calibri"/>
               </a:rPr>
               <a:t>siamo</a:t>
             </a:r>
             <a:r>
-              <a:rPr lang="en-US">
+              <a:rPr lang="en-US" sz="1400" dirty="0">
                 <a:cs typeface="Calibri"/>
               </a:rPr>
               <a:t> tutti </a:t>
             </a:r>
             <a:r>
-              <a:rPr lang="en-US" err="1">
+              <a:rPr lang="en-US" sz="1400" dirty="0" err="1">
                 <a:cs typeface="Calibri"/>
               </a:rPr>
               <a:t>delle</a:t>
             </a:r>
             <a:r>
-              <a:rPr lang="en-US">
+              <a:rPr lang="en-US" sz="1400" dirty="0">
                 <a:cs typeface="Calibri"/>
               </a:rPr>
               <a:t> </a:t>
             </a:r>
             <a:r>
-              <a:rPr lang="en-US" err="1">
+              <a:rPr lang="en-US" sz="1400" dirty="0" err="1">
                 <a:cs typeface="Calibri"/>
               </a:rPr>
               <a:t>merde</a:t>
             </a:r>
             <a:r>
-              <a:rPr lang="en-US">
+              <a:rPr lang="en-US" sz="1400" dirty="0">
                 <a:cs typeface="Calibri"/>
               </a:rPr>
               <a:t> </a:t>
             </a:r>
             <a:r>
-              <a:rPr lang="en-US" err="1">
+              <a:rPr lang="en-US" sz="1400" dirty="0" err="1">
                 <a:cs typeface="Calibri"/>
               </a:rPr>
               <a:t>calpestate</a:t>
             </a:r>
             <a:r>
-              <a:rPr lang="en-US">
+              <a:rPr lang="en-US" sz="1400" dirty="0">
                 <a:cs typeface="Calibri"/>
               </a:rPr>
               <a:t> da </a:t>
             </a:r>
             <a:r>
-              <a:rPr lang="en-US" err="1">
+              <a:rPr lang="en-US" sz="1400" dirty="0" err="1">
                 <a:cs typeface="Calibri"/>
               </a:rPr>
               <a:t>Tocchetti</a:t>
             </a:r>
             <a:r>
-              <a:rPr lang="en-US">
+              <a:rPr lang="en-US" dirty="0">
                 <a:cs typeface="Calibri"/>
               </a:rPr>
               <a:t>.</a:t>
             </a:r>
-            <a:endParaRPr lang="en-US" err="1"/>
+          </a:p>
+          <a:p>
+            <a:r>
+              <a:rPr lang="en-US" dirty="0" err="1">
+                <a:cs typeface="Calibri"/>
+              </a:rPr>
+              <a:t>Politecnico</a:t>
+            </a:r>
+            <a:r>
+              <a:rPr lang="en-US" dirty="0">
+                <a:cs typeface="Calibri"/>
+              </a:rPr>
+              <a:t> di </a:t>
+            </a:r>
+            <a:r>
+              <a:rPr lang="en-US" dirty="0" err="1">
+                <a:cs typeface="Calibri"/>
+              </a:rPr>
+              <a:t>MIlano</a:t>
+            </a:r>
+            <a:r>
+              <a:rPr lang="en-US" dirty="0">
+                <a:cs typeface="Calibri"/>
+              </a:rPr>
+              <a:t>, </a:t>
+            </a:r>
+            <a:r>
+              <a:rPr lang="en-US" dirty="0" err="1">
+                <a:cs typeface="Calibri"/>
+              </a:rPr>
+              <a:t>Gli</a:t>
+            </a:r>
+            <a:r>
+              <a:rPr lang="en-US" dirty="0">
+                <a:cs typeface="Calibri"/>
+              </a:rPr>
+              <a:t> </a:t>
+            </a:r>
+            <a:r>
+              <a:rPr lang="en-US" dirty="0" err="1">
+                <a:cs typeface="Calibri"/>
+              </a:rPr>
+              <a:t>sputatori</a:t>
+            </a:r>
+            <a:r>
+              <a:rPr lang="en-US" dirty="0">
+                <a:cs typeface="Calibri"/>
+              </a:rPr>
+              <a:t>:</a:t>
+            </a:r>
+          </a:p>
+          <a:p>
+            <a:r>
+              <a:rPr lang="en-US" dirty="0">
+                <a:cs typeface="Calibri"/>
+              </a:rPr>
+              <a:t>Dr. Andrea </a:t>
+            </a:r>
+            <a:r>
+              <a:rPr lang="en-US" dirty="0" err="1">
+                <a:cs typeface="Calibri"/>
+              </a:rPr>
+              <a:t>Tocchetti</a:t>
+            </a:r>
+            <a:r>
+              <a:rPr lang="en-US" dirty="0">
+                <a:cs typeface="Calibri"/>
+              </a:rPr>
+              <a:t> ,Prof. Marco Brambilla</a:t>
+            </a:r>
           </a:p>
         </p:txBody>
       </p:sp>
@@ -6091,8 +6297,8 @@
         </p:nvSpPr>
         <p:spPr>
           <a:xfrm>
-            <a:off x="954588" y="5534561"/>
-            <a:ext cx="6096000" cy="1323439"/>
+            <a:off x="938877" y="5228190"/>
+            <a:ext cx="6096000" cy="1815882"/>
           </a:xfrm>
           <a:prstGeom prst="rect">
             <a:avLst/>
@@ -6100,7 +6306,7 @@
           <a:noFill/>
         </p:spPr>
         <p:txBody>
-          <a:bodyPr wrap="square">
+          <a:bodyPr wrap="square" lIns="91440" tIns="45720" rIns="91440" bIns="45720" anchor="t">
             <a:spAutoFit/>
           </a:bodyPr>
           <a:lstStyle/>
@@ -6108,23 +6314,10 @@
             <a:r>
               <a:rPr lang="en-GB" sz="1600" b="0" i="0" dirty="0">
                 <a:effectLst/>
-                <a:latin typeface="Arial" panose="020B0604020202020204" pitchFamily="34" charset="0"/>
-              </a:rPr>
-              <a:t>Francesco </a:t>
-            </a:r>
-            <a:r>
-              <a:rPr lang="en-GB" sz="1600" b="0" i="0" dirty="0" err="1">
-                <a:effectLst/>
-                <a:latin typeface="Arial" panose="020B0604020202020204" pitchFamily="34" charset="0"/>
-              </a:rPr>
-              <a:t>Riccardi</a:t>
-            </a:r>
-            <a:r>
-              <a:rPr lang="en-GB" sz="1600" b="0" i="0" dirty="0">
-                <a:effectLst/>
-                <a:latin typeface="Arial" panose="020B0604020202020204" pitchFamily="34" charset="0"/>
-              </a:rPr>
-              <a:t> (10651584)</a:t>
+                <a:latin typeface="Arial"/>
+                <a:cs typeface="Arial"/>
+              </a:rPr>
+              <a:t>Francesco Riccardi (10651584)</a:t>
             </a:r>
             <a:br>
               <a:rPr lang="en-GB" sz="1600" dirty="0"/>
@@ -6132,23 +6325,10 @@
             <a:r>
               <a:rPr lang="en-GB" sz="1600" b="0" i="0" dirty="0">
                 <a:effectLst/>
-                <a:latin typeface="Arial" panose="020B0604020202020204" pitchFamily="34" charset="0"/>
-              </a:rPr>
-              <a:t>Alessandro </a:t>
-            </a:r>
-            <a:r>
-              <a:rPr lang="en-GB" sz="1600" b="0" i="0" dirty="0" err="1">
-                <a:effectLst/>
-                <a:latin typeface="Arial" panose="020B0604020202020204" pitchFamily="34" charset="0"/>
-              </a:rPr>
-              <a:t>Romito</a:t>
-            </a:r>
-            <a:r>
-              <a:rPr lang="en-GB" sz="1600" b="0" i="0" dirty="0">
-                <a:effectLst/>
-                <a:latin typeface="Arial" panose="020B0604020202020204" pitchFamily="34" charset="0"/>
-              </a:rPr>
-              <a:t> (10661916)</a:t>
+                <a:latin typeface="Arial"/>
+                <a:cs typeface="Arial"/>
+              </a:rPr>
+              <a:t>Alessandro Romito (10661916)</a:t>
             </a:r>
             <a:br>
               <a:rPr lang="en-GB" sz="1600" dirty="0"/>
@@ -6156,23 +6336,10 @@
             <a:r>
               <a:rPr lang="en-GB" sz="1600" b="0" i="0" dirty="0">
                 <a:effectLst/>
-                <a:latin typeface="Arial" panose="020B0604020202020204" pitchFamily="34" charset="0"/>
-              </a:rPr>
-              <a:t>Marco Luca </a:t>
-            </a:r>
-            <a:r>
-              <a:rPr lang="en-GB" sz="1600" b="0" i="0" dirty="0" err="1">
-                <a:effectLst/>
-                <a:latin typeface="Arial" panose="020B0604020202020204" pitchFamily="34" charset="0"/>
-              </a:rPr>
-              <a:t>Previtera</a:t>
-            </a:r>
-            <a:r>
-              <a:rPr lang="en-GB" sz="1600" b="0" i="0" dirty="0">
-                <a:effectLst/>
-                <a:latin typeface="Arial" panose="020B0604020202020204" pitchFamily="34" charset="0"/>
-              </a:rPr>
-              <a:t> (10682248)</a:t>
+                <a:latin typeface="Arial"/>
+                <a:cs typeface="Arial"/>
+              </a:rPr>
+              <a:t>Marco Luca Previtera (10682248)</a:t>
             </a:r>
             <a:br>
               <a:rPr lang="en-GB" sz="1600" dirty="0"/>
@@ -6180,23 +6347,10 @@
             <a:r>
               <a:rPr lang="en-GB" sz="1600" b="0" i="0" dirty="0">
                 <a:effectLst/>
-                <a:latin typeface="Arial" panose="020B0604020202020204" pitchFamily="34" charset="0"/>
-              </a:rPr>
-              <a:t>Simone Lo </a:t>
-            </a:r>
-            <a:r>
-              <a:rPr lang="en-GB" sz="1600" b="0" i="0" dirty="0" err="1">
-                <a:effectLst/>
-                <a:latin typeface="Arial" panose="020B0604020202020204" pitchFamily="34" charset="0"/>
-              </a:rPr>
-              <a:t>Gatto</a:t>
-            </a:r>
-            <a:r>
-              <a:rPr lang="en-GB" sz="1600" b="0" i="0" dirty="0">
-                <a:effectLst/>
-                <a:latin typeface="Arial" panose="020B0604020202020204" pitchFamily="34" charset="0"/>
-              </a:rPr>
-              <a:t> (10736180)</a:t>
+                <a:latin typeface="Arial"/>
+                <a:cs typeface="Arial"/>
+              </a:rPr>
+              <a:t>Simone Lo Gatto (10736180)</a:t>
             </a:r>
             <a:br>
               <a:rPr lang="en-GB" sz="1600" dirty="0"/>
@@ -6204,58 +6358,34 @@
             <a:r>
               <a:rPr lang="en-GB" sz="1600" b="0" i="0" dirty="0">
                 <a:effectLst/>
-                <a:latin typeface="Arial" panose="020B0604020202020204" pitchFamily="34" charset="0"/>
+                <a:latin typeface="Arial"/>
+                <a:cs typeface="Arial"/>
               </a:rPr>
               <a:t>Lorenzo Ferretti(10713719)</a:t>
             </a:r>
           </a:p>
-        </p:txBody>
-      </p:sp>
-      <p:pic>
-        <p:nvPicPr>
-          <p:cNvPr id="1026" name="Picture 2" descr="41,503 Big Data Stock Photos - Free &amp; Royalty-Free Stock Photos from  Dreamstime">
-            <a:extLst>
-              <a:ext uri="{FF2B5EF4-FFF2-40B4-BE49-F238E27FC236}">
-                <a16:creationId xmlns:a16="http://schemas.microsoft.com/office/drawing/2014/main" id="{EB8EB7EE-659F-07C9-A2F3-8B871CF80120}"/>
-              </a:ext>
-            </a:extLst>
-          </p:cNvPr>
-          <p:cNvPicPr>
-            <a:picLocks noChangeAspect="1" noChangeArrowheads="1"/>
-          </p:cNvPicPr>
-          <p:nvPr/>
-        </p:nvPicPr>
-        <p:blipFill rotWithShape="1">
-          <a:blip r:embed="rId2">
-            <a:extLst>
-              <a:ext uri="{28A0092B-C50C-407E-A947-70E740481C1C}">
-                <a14:useLocalDpi xmlns:a14="http://schemas.microsoft.com/office/drawing/2010/main" val="0"/>
-              </a:ext>
-            </a:extLst>
-          </a:blip>
-          <a:srcRect t="5926" r="935" b="17778"/>
-          <a:stretch/>
-        </p:blipFill>
-        <p:spPr bwMode="auto">
-          <a:xfrm>
-            <a:off x="8923867" y="0"/>
-            <a:ext cx="3268133" cy="1684488"/>
-          </a:xfrm>
-          <a:prstGeom prst="rect">
-            <a:avLst/>
-          </a:prstGeom>
-          <a:noFill/>
-          <a:extLst>
-            <a:ext uri="{909E8E84-426E-40DD-AFC4-6F175D3DCCD1}">
-              <a14:hiddenFill xmlns:a14="http://schemas.microsoft.com/office/drawing/2010/main">
-                <a:solidFill>
-                  <a:srgbClr val="FFFFFF"/>
-                </a:solidFill>
-              </a14:hiddenFill>
-            </a:ext>
-          </a:extLst>
-        </p:spPr>
-      </p:pic>
+          <a:p>
+            <a:r>
+              <a:rPr lang="en-GB" sz="1600" dirty="0">
+                <a:latin typeface="Arial"/>
+                <a:cs typeface="Arial"/>
+              </a:rPr>
+              <a:t>Group-09</a:t>
+            </a:r>
+            <a:endParaRPr lang="en-GB" sz="1600">
+              <a:latin typeface="Arial"/>
+              <a:ea typeface="+mn-lt"/>
+              <a:cs typeface="+mn-lt"/>
+            </a:endParaRPr>
+          </a:p>
+          <a:p>
+            <a:endParaRPr lang="en-GB" sz="1600" dirty="0">
+              <a:latin typeface="Arial" panose="020B0604020202020204" pitchFamily="34" charset="0"/>
+              <a:cs typeface="Arial"/>
+            </a:endParaRPr>
+          </a:p>
+        </p:txBody>
+      </p:sp>
       <p:sp>
         <p:nvSpPr>
           <p:cNvPr id="4" name="Rectangle 3">
@@ -6270,7 +6400,7 @@
         </p:nvSpPr>
         <p:spPr>
           <a:xfrm>
-            <a:off x="2988755" y="2136338"/>
+            <a:off x="2470281" y="2136338"/>
             <a:ext cx="5100638" cy="2585323"/>
           </a:xfrm>
           <a:prstGeom prst="rect">
@@ -6344,8 +6474,8 @@
         </p:nvSpPr>
         <p:spPr>
           <a:xfrm>
-            <a:off x="5922383" y="5954299"/>
-            <a:ext cx="6100762" cy="646331"/>
+            <a:off x="6087352" y="5035186"/>
+            <a:ext cx="6100762" cy="1754326"/>
           </a:xfrm>
           <a:prstGeom prst="rect">
             <a:avLst/>
@@ -6353,29 +6483,10 @@
           <a:noFill/>
         </p:spPr>
         <p:txBody>
-          <a:bodyPr wrap="square">
+          <a:bodyPr wrap="square" lIns="91440" tIns="45720" rIns="91440" bIns="45720" anchor="t">
             <a:spAutoFit/>
           </a:bodyPr>
           <a:lstStyle/>
-          <a:p>
-            <a:pPr algn="r"/>
-            <a:r>
-              <a:rPr lang="en-GB" dirty="0">
-                <a:solidFill>
-                  <a:schemeClr val="bg1"/>
-                </a:solidFill>
-                <a:latin typeface="Arial" panose="020B0604020202020204" pitchFamily="34" charset="0"/>
-              </a:rPr>
-              <a:t>Group-09</a:t>
-            </a:r>
-            <a:endParaRPr lang="en-GB" b="0" i="0" dirty="0">
-              <a:solidFill>
-                <a:schemeClr val="bg1"/>
-              </a:solidFill>
-              <a:effectLst/>
-              <a:latin typeface="Arial" panose="020B0604020202020204" pitchFamily="34" charset="0"/>
-            </a:endParaRPr>
-          </a:p>
           <a:p>
             <a:pPr algn="r"/>
             <a:r>
@@ -6391,10 +6502,126 @@
               <a:solidFill>
                 <a:schemeClr val="bg1"/>
               </a:solidFill>
+              <a:latin typeface="Arial" panose="020B0604020202020204" pitchFamily="34" charset="0"/>
+              <a:cs typeface="Arial" panose="020B0604020202020204"/>
             </a:endParaRPr>
           </a:p>
-        </p:txBody>
-      </p:sp>
+          <a:p>
+            <a:pPr algn="r"/>
+            <a:r>
+              <a:rPr lang="en-GB" dirty="0" err="1">
+                <a:solidFill>
+                  <a:schemeClr val="bg1"/>
+                </a:solidFill>
+                <a:cs typeface="Arial"/>
+              </a:rPr>
+              <a:t>Politecnico</a:t>
+            </a:r>
+            <a:r>
+              <a:rPr lang="en-GB" dirty="0">
+                <a:solidFill>
+                  <a:schemeClr val="bg1"/>
+                </a:solidFill>
+                <a:cs typeface="Arial"/>
+              </a:rPr>
+              <a:t> di Milano</a:t>
+            </a:r>
+          </a:p>
+          <a:p>
+            <a:pPr algn="r"/>
+            <a:endParaRPr lang="en-GB" dirty="0">
+              <a:solidFill>
+                <a:schemeClr val="bg1"/>
+              </a:solidFill>
+              <a:cs typeface="Arial"/>
+            </a:endParaRPr>
+          </a:p>
+          <a:p>
+            <a:pPr algn="r"/>
+            <a:r>
+              <a:rPr lang="en-GB" dirty="0">
+                <a:solidFill>
+                  <a:schemeClr val="bg1"/>
+                </a:solidFill>
+                <a:cs typeface="Arial"/>
+              </a:rPr>
+              <a:t>Professors:</a:t>
+            </a:r>
+          </a:p>
+          <a:p>
+            <a:pPr algn="r"/>
+            <a:r>
+              <a:rPr lang="en-GB" dirty="0">
+                <a:solidFill>
+                  <a:schemeClr val="bg1"/>
+                </a:solidFill>
+                <a:cs typeface="Arial"/>
+              </a:rPr>
+              <a:t>Prof. Marco Brambilla</a:t>
+            </a:r>
+          </a:p>
+          <a:p>
+            <a:pPr algn="r"/>
+            <a:r>
+              <a:rPr lang="en-GB" dirty="0" err="1">
+                <a:solidFill>
+                  <a:schemeClr val="bg1"/>
+                </a:solidFill>
+                <a:cs typeface="Arial"/>
+              </a:rPr>
+              <a:t>Dr.</a:t>
+            </a:r>
+            <a:r>
+              <a:rPr lang="en-GB" dirty="0">
+                <a:solidFill>
+                  <a:schemeClr val="bg1"/>
+                </a:solidFill>
+                <a:cs typeface="Arial"/>
+              </a:rPr>
+              <a:t> Andrea </a:t>
+            </a:r>
+            <a:r>
+              <a:rPr lang="en-GB" dirty="0" err="1">
+                <a:solidFill>
+                  <a:schemeClr val="bg1"/>
+                </a:solidFill>
+                <a:cs typeface="Arial"/>
+              </a:rPr>
+              <a:t>Tocchetti</a:t>
+            </a:r>
+          </a:p>
+        </p:txBody>
+      </p:sp>
+      <p:pic>
+        <p:nvPicPr>
+          <p:cNvPr id="2" name="Immagine 5">
+            <a:extLst>
+              <a:ext uri="{FF2B5EF4-FFF2-40B4-BE49-F238E27FC236}">
+                <a16:creationId xmlns:a16="http://schemas.microsoft.com/office/drawing/2014/main" id="{8E3B592B-882C-27FF-8A0A-FBE0BCFB4D02}"/>
+              </a:ext>
+            </a:extLst>
+          </p:cNvPr>
+          <p:cNvPicPr>
+            <a:picLocks noChangeAspect="1"/>
+          </p:cNvPicPr>
+          <p:nvPr/>
+        </p:nvPicPr>
+        <p:blipFill>
+          <a:blip r:embed="rId2"/>
+          <a:stretch>
+            <a:fillRect/>
+          </a:stretch>
+        </p:blipFill>
+        <p:spPr>
+          <a:xfrm>
+            <a:off x="8935040" y="-249"/>
+            <a:ext cx="3245962" cy="2600725"/>
+          </a:xfrm>
+          <a:prstGeom prst="rect">
+            <a:avLst/>
+          </a:prstGeom>
+        </p:spPr>
+      </p:pic>
     </p:spTree>
     <p:extLst>
       <p:ext uri="{BB962C8B-B14F-4D97-AF65-F5344CB8AC3E}">
@@ -6516,13 +6743,13 @@
   <p:clrMapOvr>
     <a:masterClrMapping/>
   </p:clrMapOvr>
-  <mc:AlternateContent xmlns:mc="http://schemas.openxmlformats.org/markup-compatibility/2006">
-    <mc:Choice xmlns:p14="http://schemas.microsoft.com/office/powerpoint/2010/main" Requires="p14">
+  <mc:AlternateContent xmlns:mc="http://schemas.openxmlformats.org/markup-compatibility/2006" xmlns:p14="http://schemas.microsoft.com/office/powerpoint/2010/main">
+    <mc:Choice Requires="p14">
       <p:transition spd="med" p14:dur="700">
         <p:fade/>
       </p:transition>
     </mc:Choice>
-    <mc:Fallback>
+    <mc:Fallback xmlns="">
       <p:transition spd="med">
         <p:fade/>
       </p:transition>
@@ -7256,13 +7483,13 @@
   <p:clrMapOvr>
     <a:masterClrMapping/>
   </p:clrMapOvr>
-  <mc:AlternateContent xmlns:mc="http://schemas.openxmlformats.org/markup-compatibility/2006">
-    <mc:Choice xmlns:p14="http://schemas.microsoft.com/office/powerpoint/2010/main" Requires="p14">
+  <mc:AlternateContent xmlns:mc="http://schemas.openxmlformats.org/markup-compatibility/2006" xmlns:p14="http://schemas.microsoft.com/office/powerpoint/2010/main">
+    <mc:Choice Requires="p14">
       <p:transition spd="med" p14:dur="700">
         <p:fade/>
       </p:transition>
     </mc:Choice>
-    <mc:Fallback>
+    <mc:Fallback xmlns="">
       <p:transition spd="med">
         <p:fade/>
       </p:transition>
@@ -7740,13 +7967,13 @@
   <p:clrMapOvr>
     <a:masterClrMapping/>
   </p:clrMapOvr>
-  <mc:AlternateContent xmlns:mc="http://schemas.openxmlformats.org/markup-compatibility/2006">
-    <mc:Choice xmlns:p14="http://schemas.microsoft.com/office/powerpoint/2010/main" Requires="p14">
+  <mc:AlternateContent xmlns:mc="http://schemas.openxmlformats.org/markup-compatibility/2006" xmlns:p14="http://schemas.microsoft.com/office/powerpoint/2010/main">
+    <mc:Choice Requires="p14">
       <p:transition spd="med" p14:dur="700">
         <p:fade/>
       </p:transition>
     </mc:Choice>
-    <mc:Fallback>
+    <mc:Fallback xmlns="">
       <p:transition spd="med">
         <p:fade/>
       </p:transition>
@@ -7870,13 +8097,13 @@
   <p:clrMapOvr>
     <a:masterClrMapping/>
   </p:clrMapOvr>
-  <mc:AlternateContent xmlns:mc="http://schemas.openxmlformats.org/markup-compatibility/2006">
-    <mc:Choice xmlns:p14="http://schemas.microsoft.com/office/powerpoint/2010/main" Requires="p14">
+  <mc:AlternateContent xmlns:mc="http://schemas.openxmlformats.org/markup-compatibility/2006" xmlns:p14="http://schemas.microsoft.com/office/powerpoint/2010/main">
+    <mc:Choice Requires="p14">
       <p:transition spd="med" p14:dur="700">
         <p:fade/>
       </p:transition>
     </mc:Choice>
-    <mc:Fallback>
+    <mc:Fallback xmlns="">
       <p:transition spd="med">
         <p:fade/>
       </p:transition>
@@ -7976,13 +8203,13 @@
   <p:clrMapOvr>
     <a:masterClrMapping/>
   </p:clrMapOvr>
-  <mc:AlternateContent xmlns:mc="http://schemas.openxmlformats.org/markup-compatibility/2006">
-    <mc:Choice xmlns:p14="http://schemas.microsoft.com/office/powerpoint/2010/main" Requires="p14">
+  <mc:AlternateContent xmlns:mc="http://schemas.openxmlformats.org/markup-compatibility/2006" xmlns:p14="http://schemas.microsoft.com/office/powerpoint/2010/main">
+    <mc:Choice Requires="p14">
       <p:transition spd="med" p14:dur="700">
         <p:fade/>
       </p:transition>
     </mc:Choice>
-    <mc:Fallback>
+    <mc:Fallback xmlns="">
       <p:transition spd="med">
         <p:fade/>
       </p:transition>
@@ -8412,6 +8639,36 @@
           </a:p>
         </p:txBody>
       </p:sp>
+      <p:pic>
+        <p:nvPicPr>
+          <p:cNvPr id="4" name="Immagine 5" descr="Immagine che contiene testo&#10;&#10;Descrizione generata automaticamente">
+            <a:extLst>
+              <a:ext uri="{FF2B5EF4-FFF2-40B4-BE49-F238E27FC236}">
+                <a16:creationId xmlns:a16="http://schemas.microsoft.com/office/drawing/2014/main" id="{E02AD754-C79A-99CE-3C00-38A8F37E5DF8}"/>
+              </a:ext>
+            </a:extLst>
+          </p:cNvPr>
+          <p:cNvPicPr>
+            <a:picLocks noChangeAspect="1"/>
+          </p:cNvPicPr>
+          <p:nvPr/>
+        </p:nvPicPr>
+        <p:blipFill>
+          <a:blip r:embed="rId2"/>
+          <a:stretch>
+            <a:fillRect/>
+          </a:stretch>
+        </p:blipFill>
+        <p:spPr>
+          <a:xfrm>
+            <a:off x="8832916" y="5129561"/>
+            <a:ext cx="3355942" cy="1725698"/>
+          </a:xfrm>
+          <a:prstGeom prst="rect">
+            <a:avLst/>
+          </a:prstGeom>
+        </p:spPr>
+      </p:pic>
     </p:spTree>
     <p:extLst>
       <p:ext uri="{BB962C8B-B14F-4D97-AF65-F5344CB8AC3E}">
@@ -8422,13 +8679,13 @@
   <p:clrMapOvr>
     <a:masterClrMapping/>
   </p:clrMapOvr>
-  <mc:AlternateContent xmlns:mc="http://schemas.openxmlformats.org/markup-compatibility/2006">
-    <mc:Choice xmlns:p14="http://schemas.microsoft.com/office/powerpoint/2010/main" Requires="p14">
+  <mc:AlternateContent xmlns:mc="http://schemas.openxmlformats.org/markup-compatibility/2006" xmlns:p14="http://schemas.microsoft.com/office/powerpoint/2010/main">
+    <mc:Choice Requires="p14">
       <p:transition spd="med" p14:dur="700">
         <p:fade/>
       </p:transition>
     </mc:Choice>
-    <mc:Fallback>
+    <mc:Fallback xmlns="">
       <p:transition spd="med">
         <p:fade/>
       </p:transition>
@@ -8656,13 +8913,13 @@
   <p:clrMapOvr>
     <a:masterClrMapping/>
   </p:clrMapOvr>
-  <mc:AlternateContent xmlns:mc="http://schemas.openxmlformats.org/markup-compatibility/2006">
-    <mc:Choice xmlns:p14="http://schemas.microsoft.com/office/powerpoint/2010/main" Requires="p14">
+  <mc:AlternateContent xmlns:mc="http://schemas.openxmlformats.org/markup-compatibility/2006" xmlns:p14="http://schemas.microsoft.com/office/powerpoint/2010/main">
+    <mc:Choice Requires="p14">
       <p:transition spd="med" p14:dur="700">
         <p:fade/>
       </p:transition>
     </mc:Choice>
-    <mc:Fallback>
+    <mc:Fallback xmlns="">
       <p:transition spd="med">
         <p:fade/>
       </p:transition>
@@ -8847,13 +9104,13 @@
   <p:clrMapOvr>
     <a:masterClrMapping/>
   </p:clrMapOvr>
-  <mc:AlternateContent xmlns:mc="http://schemas.openxmlformats.org/markup-compatibility/2006">
-    <mc:Choice xmlns:p14="http://schemas.microsoft.com/office/powerpoint/2010/main" Requires="p14">
+  <mc:AlternateContent xmlns:mc="http://schemas.openxmlformats.org/markup-compatibility/2006" xmlns:p14="http://schemas.microsoft.com/office/powerpoint/2010/main">
+    <mc:Choice Requires="p14">
       <p:transition spd="med" p14:dur="700">
         <p:fade/>
       </p:transition>
     </mc:Choice>
-    <mc:Fallback>
+    <mc:Fallback xmlns="">
       <p:transition spd="med">
         <p:fade/>
       </p:transition>
@@ -8907,7 +9164,7 @@
           </a:bodyPr>
           <a:lstStyle/>
           <a:p>
-            <a:pPr>
+            <a:pPr marL="344170" indent="-344170">
               <a:buClr>
                 <a:schemeClr val="bg1"/>
               </a:buClr>
@@ -8966,7 +9223,7 @@
                   <a:schemeClr val="bg1"/>
                 </a:solidFill>
               </a:rPr>
-              <a:t>, Publication, University and Serie are Node labels and their attributes are shown in the graph diagram near. The relationships of the database are WRITTEN\_BY, CONTAIN, PUBLICATED\_BY, COAUTHOR, AT, CITE, INCLUDE. We omitted some links using the publication note make graph diagram more readable and </a:t>
+              <a:t>, Publication, University and Serie are Node labels and their attributes are shown in the graph diagram near. The relationships of the database are WRITTEN_BY, CONTAIN, PUBLICATED_BY, COAUTHOR, AT, CITE, INCLUDE. We omitted some links using the publication note make graph diagram more readable and </a:t>
             </a:r>
             <a:r>
               <a:rPr lang="en-GB" dirty="0" err="1">
@@ -9030,21 +9287,24 @@
                   <a:schemeClr val="bg1"/>
                 </a:solidFill>
               </a:rPr>
-              <a:t> contain the Publication tag in order to perform and understand queries easily since you don't need to specify 7 different nodes in the MATCH statement every time. </a:t>
+              <a:t> contain the Publication tag in order to perform and understand queries easily since you don't need to specify 7 different nodes in the MATCH statement every time. </a:t>
             </a:r>
             <a:endParaRPr lang="en-IT" dirty="0">
               <a:solidFill>
                 <a:schemeClr val="bg1"/>
               </a:solidFill>
+              <a:cs typeface="Arial" panose="020B0604020202020204"/>
             </a:endParaRPr>
           </a:p>
           <a:p>
-            <a:pPr>
+            <a:pPr marL="344170" indent="-344170">
               <a:buClr>
                 <a:schemeClr val="bg1"/>
               </a:buClr>
             </a:pPr>
-            <a:endParaRPr lang="en-IT" dirty="0"/>
+            <a:endParaRPr lang="en-IT" dirty="0">
+              <a:cs typeface="Arial" panose="020B0604020202020204"/>
+            </a:endParaRPr>
           </a:p>
         </p:txBody>
       </p:sp>
@@ -9094,13 +9354,13 @@
   <p:clrMapOvr>
     <a:masterClrMapping/>
   </p:clrMapOvr>
-  <mc:AlternateContent xmlns:mc="http://schemas.openxmlformats.org/markup-compatibility/2006">
-    <mc:Choice xmlns:p14="http://schemas.microsoft.com/office/powerpoint/2010/main" Requires="p14">
+  <mc:AlternateContent xmlns:mc="http://schemas.openxmlformats.org/markup-compatibility/2006" xmlns:p14="http://schemas.microsoft.com/office/powerpoint/2010/main">
+    <mc:Choice Requires="p14">
       <p:transition spd="med" p14:dur="700">
         <p:fade/>
       </p:transition>
     </mc:Choice>
-    <mc:Fallback>
+    <mc:Fallback xmlns="">
       <p:transition spd="med">
         <p:fade/>
       </p:transition>
@@ -9475,13 +9735,13 @@
   <p:clrMapOvr>
     <a:masterClrMapping/>
   </p:clrMapOvr>
-  <mc:AlternateContent xmlns:mc="http://schemas.openxmlformats.org/markup-compatibility/2006">
-    <mc:Choice xmlns:p14="http://schemas.microsoft.com/office/powerpoint/2010/main" Requires="p14">
+  <mc:AlternateContent xmlns:mc="http://schemas.openxmlformats.org/markup-compatibility/2006" xmlns:p14="http://schemas.microsoft.com/office/powerpoint/2010/main">
+    <mc:Choice Requires="p14">
       <p:transition spd="med" p14:dur="700">
         <p:fade/>
       </p:transition>
     </mc:Choice>
-    <mc:Fallback>
+    <mc:Fallback xmlns="">
       <p:transition spd="med">
         <p:fade/>
       </p:transition>
@@ -9902,13 +10162,13 @@
   <p:clrMapOvr>
     <a:masterClrMapping/>
   </p:clrMapOvr>
-  <mc:AlternateContent xmlns:mc="http://schemas.openxmlformats.org/markup-compatibility/2006">
-    <mc:Choice xmlns:p14="http://schemas.microsoft.com/office/powerpoint/2010/main" Requires="p14">
+  <mc:AlternateContent xmlns:mc="http://schemas.openxmlformats.org/markup-compatibility/2006" xmlns:p14="http://schemas.microsoft.com/office/powerpoint/2010/main">
+    <mc:Choice Requires="p14">
       <p:transition spd="med" p14:dur="700">
         <p:fade/>
       </p:transition>
     </mc:Choice>
-    <mc:Fallback>
+    <mc:Fallback xmlns="">
       <p:transition spd="med">
         <p:fade/>
       </p:transition>
@@ -10055,13 +10315,13 @@
   <p:clrMapOvr>
     <a:masterClrMapping/>
   </p:clrMapOvr>
-  <mc:AlternateContent xmlns:mc="http://schemas.openxmlformats.org/markup-compatibility/2006">
-    <mc:Choice xmlns:p14="http://schemas.microsoft.com/office/powerpoint/2010/main" Requires="p14">
+  <mc:AlternateContent xmlns:mc="http://schemas.openxmlformats.org/markup-compatibility/2006" xmlns:p14="http://schemas.microsoft.com/office/powerpoint/2010/main">
+    <mc:Choice Requires="p14">
       <p:transition spd="med" p14:dur="700">
         <p:fade/>
       </p:transition>
     </mc:Choice>
-    <mc:Fallback>
+    <mc:Fallback xmlns="">
       <p:transition spd="med">
         <p:fade/>
       </p:transition>
@@ -10484,13 +10744,13 @@
   <p:clrMapOvr>
     <a:masterClrMapping/>
   </p:clrMapOvr>
-  <mc:AlternateContent xmlns:mc="http://schemas.openxmlformats.org/markup-compatibility/2006">
-    <mc:Choice xmlns:p14="http://schemas.microsoft.com/office/powerpoint/2010/main" Requires="p14">
+  <mc:AlternateContent xmlns:mc="http://schemas.openxmlformats.org/markup-compatibility/2006" xmlns:p14="http://schemas.microsoft.com/office/powerpoint/2010/main">
+    <mc:Choice Requires="p14">
       <p:transition spd="med" p14:dur="700">
         <p:fade/>
       </p:transition>
     </mc:Choice>
-    <mc:Fallback>
+    <mc:Fallback xmlns="">
       <p:transition spd="med">
         <p:fade/>
       </p:transition>

</xml_diff>